<commit_message>
Stage 8 review fixes: C-012
</commit_message>
<xml_diff>
--- a/output/archive/Archive/Users/mrinalvesi_old_laptop/DMPK/Working/DMPK_Clearance_031714_v2.pptx
+++ b/output/archive/Archive/Users/mrinalvesi_old_laptop/DMPK/Working/DMPK_Clearance_031714_v2.pptx
@@ -4185,7 +4185,7 @@
               <a:rPr sz="2000">
                 <a:latin typeface="Times New Roman"/>
               </a:rPr>
-              <a:t>Decide whether the exposure memo quotes both CLint values or only the protein-normalised one</a:t>
+              <a:t>Decide which assay informs the exposure memo, with its own normalisation basis stated</a:t>
             </a:r>
           </a:p>
           <a:p>
@@ -4541,7 +4541,7 @@
               <a:rPr sz="2000">
                 <a:latin typeface="Times New Roman"/>
               </a:rPr>
-              <a:t>Verapamil and ketoconazole used as reference compounds for both assays</a:t>
+              <a:t>Reference compounds selected for the species and assay conditions in the study protocol</a:t>
             </a:r>
           </a:p>
           <a:p>
@@ -4550,7 +4550,7 @@
               <a:rPr sz="2000">
                 <a:latin typeface="Times New Roman"/>
               </a:rPr>
-              <a:t>Reference values checked at the start of each run against the lab's historical window</a:t>
+              <a:t>Reference performance checked against the assay-specific acceptance criteria</a:t>
             </a:r>
           </a:p>
           <a:p>
@@ -4559,7 +4559,7 @@
               <a:rPr sz="2000">
                 <a:latin typeface="Times New Roman"/>
               </a:rPr>
-              <a:t>Generic reagent lots recorded on the assay worksheet</a:t>
+              <a:t>Reagent and cell lot references recorded on the assay worksheet</a:t>
             </a:r>
           </a:p>
         </p:txBody>
@@ -4995,7 +4995,7 @@
                         <a:rPr sz="1400">
                           <a:latin typeface="Times New Roman"/>
                         </a:rPr>
-                        <a:t>Liver microsomes, pooled</a:t>
+                        <a:t>Liver microsomes; preparation recorded on the assay worksheet</a:t>
                       </a:r>
                     </a:p>
                   </a:txBody>
@@ -5010,7 +5010,7 @@
                         <a:rPr sz="1400">
                           <a:latin typeface="Times New Roman"/>
                         </a:rPr>
-                        <a:t>Cryopreserved hepatocytes, single lot per species</a:t>
+                        <a:t>Hepatocytes; lot and donor information recorded on the assay worksheet</a:t>
                       </a:r>
                     </a:p>
                   </a:txBody>
@@ -5121,7 +5121,7 @@
                         <a:rPr sz="1400">
                           <a:latin typeface="Times New Roman"/>
                         </a:rPr>
-                        <a:t>Species run</a:t>
+                        <a:t>Species</a:t>
                       </a:r>
                     </a:p>
                   </a:txBody>
@@ -5136,7 +5136,7 @@
                         <a:rPr sz="1400">
                           <a:latin typeface="Times New Roman"/>
                         </a:rPr>
-                        <a:t>Rat, mouse, human</a:t>
+                        <a:t>As specified in the study protocol</a:t>
                       </a:r>
                     </a:p>
                   </a:txBody>
@@ -5151,7 +5151,7 @@
                         <a:rPr sz="1400">
                           <a:latin typeface="Times New Roman"/>
                         </a:rPr>
-                        <a:t>Rat and human; mouse on request</a:t>
+                        <a:t>As specified in the study protocol</a:t>
                       </a:r>
                     </a:p>
                   </a:txBody>
@@ -5183,7 +5183,7 @@
                         <a:rPr sz="1400">
                           <a:latin typeface="Times New Roman"/>
                         </a:rPr>
-                        <a:t>Intrinsic clearance, enzyme-only</a:t>
+                        <a:t>Parent depletion through microsomal metabolism under the stated cofactor conditions</a:t>
                       </a:r>
                     </a:p>
                   </a:txBody>
@@ -5198,7 +5198,7 @@
                         <a:rPr sz="1400">
                           <a:latin typeface="Times New Roman"/>
                         </a:rPr>
-                        <a:t>Intrinsic clearance including uptake and phase II</a:t>
+                        <a:t>Parent depletion in intact cells; uptake, metabolism and nonspecific loss may contribute</a:t>
                       </a:r>
                     </a:p>
                   </a:txBody>
@@ -5719,7 +5719,7 @@
               <a:rPr sz="1800">
                 <a:latin typeface="Times New Roman"/>
               </a:rPr>
-              <a:t>Rat and human microsomes run on every test article set</a:t>
+              <a:t>Confirm the species requested against each study protocol</a:t>
             </a:r>
           </a:p>
           <a:p>
@@ -5728,7 +5728,7 @@
               <a:rPr sz="1800">
                 <a:latin typeface="Times New Roman"/>
               </a:rPr>
-              <a:t>Mouse microsomes only for compounds going into rodent PK</a:t>
+              <a:t>Record microsomal preparation and protein concentration on the assay worksheet</a:t>
             </a:r>
           </a:p>
           <a:p>
@@ -5737,7 +5737,7 @@
               <a:rPr sz="1800">
                 <a:latin typeface="Times New Roman"/>
               </a:rPr>
-              <a:t>Hepatocyte lots are single-donor per species, so donor variability is not averaged out</a:t>
+              <a:t>Check hepatocyte donor composition and viable cell density in the source lot record</a:t>
             </a:r>
           </a:p>
         </p:txBody>
@@ -5769,7 +5769,7 @@
               <a:rPr sz="1800">
                 <a:latin typeface="Times New Roman"/>
               </a:rPr>
-              <a:t>Assumed: rat clearance tracks human closely enough to rank compounds</a:t>
+              <a:t>Do not assume rat clearance predicts human rank order</a:t>
             </a:r>
           </a:p>
           <a:p>
@@ -5778,7 +5778,7 @@
               <a:rPr sz="1800">
                 <a:latin typeface="Times New Roman"/>
               </a:rPr>
-              <a:t>Not checked: whether mouse hepatocytes behave like mouse microsomes</a:t>
+              <a:t>Microsomal and hepatocyte depletion can differ within the same species</a:t>
             </a:r>
           </a:p>
           <a:p>
@@ -5787,7 +5787,7 @@
               <a:rPr sz="1800">
                 <a:latin typeface="Times New Roman"/>
               </a:rPr>
-              <a:t>[TBC] human hepatocyte lot for Q2 still awaiting matrix acceptance</a:t>
+              <a:t>[TBC] check the human hepatocyte lot record before the Q2 work is scoped</a:t>
             </a:r>
           </a:p>
         </p:txBody>
@@ -5947,7 +5947,7 @@
               <a:rPr sz="2000">
                 <a:latin typeface="Times New Roman"/>
               </a:rPr>
-              <a:t>Microsomal runs: matrix acceptance uses the positive control set and the no-cofactor control</a:t>
+              <a:t>Microsomal acceptance checks include reference metabolism and the appropriate cofactor controls</a:t>
             </a:r>
           </a:p>
           <a:p>
@@ -5956,7 +5956,7 @@
               <a:rPr sz="2000">
                 <a:latin typeface="Times New Roman"/>
               </a:rPr>
-              <a:t>Hepatocyte runs: viability is checked before dosing and again at the final time point</a:t>
+              <a:t>Hepatocyte acceptance checks include viability and reference metabolism under the study conditions</a:t>
             </a:r>
           </a:p>
           <a:p>
@@ -5965,7 +5965,7 @@
               <a:rPr sz="2000">
                 <a:latin typeface="Times New Roman"/>
               </a:rPr>
-              <a:t>A run is only used if both controls fall inside their historical windows</a:t>
+              <a:t>Apply the assay-specific acceptance criteria recorded in the SOP</a:t>
             </a:r>
           </a:p>
           <a:p>
@@ -5974,7 +5974,7 @@
               <a:rPr sz="1700">
                 <a:latin typeface="Times New Roman"/>
               </a:rPr>
-              <a:t>Failed runs are repeated, not interpolated</a:t>
+              <a:t>Investigate failed acceptance before reporting clearance; document any repeat</a:t>
             </a:r>
           </a:p>
         </p:txBody>
@@ -6152,7 +6152,7 @@
               <a:rPr sz="2000">
                 <a:latin typeface="Times New Roman"/>
               </a:rPr>
-              <a:t>Depletion half-lives derived only from points inside the calibration range</a:t>
+              <a:t>Fit depletion only to quantifiable points in an appropriate log-linear interval; report slow depletion as a limit where a half-life cannot be estimated reliably</a:t>
             </a:r>
           </a:p>
         </p:txBody>

</xml_diff>